<commit_message>
Regenerate deck for the rebalanced presenter split
Slide 18 footer and notes now read Abdel Aziz, slide 25 reads Aya, and the
team card credits deposit and refund rules to Abdel Aziz. Section notes on
slides 15, 21 and 24 updated to the new handover order.
</commit_message>
<xml_diff>
--- a/docs/presentation/ChargeHub-Presentation.pptx
+++ b/docs/presentation/ChargeHub-Presentation.pptx
@@ -1058,7 +1058,7 @@
           <a:p>
             <a:r>
               <a:rPr lang="en-US" dirty="0"/>
-              <a:t>Malik. This is the heart of the project.</a:t>
+              <a:t>Malik takes the optimizer and reliability (3:10). Abdel Aziz takes the deposit and refund rules (1:00) — they are enforced in the backend he built.</a:t>
             </a:r>
             <a:endParaRPr lang="en-US" dirty="0"/>
           </a:p>
@@ -1322,7 +1322,7 @@
           <a:p>
             <a:r>
               <a:rPr lang="en-US" dirty="0"/>
-              <a:t/>
+              <a:t>Abdel Aziz — the refund rules are enforced in one backend service, and only staff can set the operator-fault flag. Say the simulated-payments line out loud before anyone asks.</a:t>
             </a:r>
             <a:endParaRPr lang="en-US" dirty="0"/>
           </a:p>
@@ -1410,7 +1410,7 @@
           <a:p>
             <a:r>
               <a:rPr lang="en-US" dirty="0"/>
-              <a:t>Aya drives the screen. Abdel Aziz operates the staff side.</a:t>
+              <a:t>Aya drives the main journey (3:30). Abdel Aziz operates the staff window throughout, then runs the three short scenes (1:30).</a:t>
             </a:r>
             <a:endParaRPr lang="en-US" dirty="0"/>
           </a:p>
@@ -1586,7 +1586,7 @@
           <a:p>
             <a:r>
               <a:rPr lang="en-US" dirty="0"/>
-              <a:t>SWITCH TO THE APP HERE. Aya drives. Follow the presenter script.</a:t>
+              <a:t>SWITCH TO THE APP HERE. Aya drives the main journey; Abdel Aziz operates the staff window and then runs the three short scenes.</a:t>
             </a:r>
             <a:endParaRPr lang="en-US" dirty="0"/>
           </a:p>
@@ -1674,7 +1674,7 @@
           <a:p>
             <a:r>
               <a:rPr lang="en-US" dirty="0"/>
-              <a:t>Aya, then Malik for the business value.</a:t>
+              <a:t>Aya takes the results, then Malik for the business value, then Aya again for what is not built.</a:t>
             </a:r>
             <a:endParaRPr lang="en-US" dirty="0"/>
           </a:p>
@@ -1938,7 +1938,7 @@
           <a:p>
             <a:r>
               <a:rPr lang="en-US" dirty="0"/>
-              <a:t>Malik. Keep it short and honest.</a:t>
+              <a:t>Aya. Keep it short and honest — three properly, one sentence for the rest.</a:t>
             </a:r>
             <a:endParaRPr lang="en-US" dirty="0"/>
           </a:p>
@@ -2026,7 +2026,7 @@
           <a:p>
             <a:r>
               <a:rPr lang="en-US" dirty="0"/>
-              <a:t/>
+              <a:t>Aya. Do not read all six — take the first three properly, then one sentence for the rest. The check-out signal is the honest one to dwell on.</a:t>
             </a:r>
             <a:endParaRPr lang="en-US" dirty="0"/>
           </a:p>
@@ -2378,7 +2378,7 @@
           <a:p>
             <a:r>
               <a:rPr lang="en-US" dirty="0"/>
-              <a:t>Malik leads Q&amp;A. Abdel Aziz takes database and implementation questions. Aya takes interface and analytics questions.</a:t>
+              <a:t>Malik leads Q&amp;A. Abdel Aziz takes database, implementation and money questions. Aya takes interface, rendering, analytics and scope questions.</a:t>
             </a:r>
             <a:endParaRPr lang="en-US" dirty="0"/>
           </a:p>
@@ -11358,7 +11358,7 @@
                 <a:ea typeface="Calibri" pitchFamily="34" charset="-122"/>
                 <a:cs typeface="Calibri" pitchFamily="34" charset="-120"/>
               </a:rPr>
-              <a:t>Malik</a:t>
+              <a:t>Abdel Aziz</a:t>
             </a:r>
             <a:endParaRPr lang="en-US" sz="1000" dirty="0"/>
           </a:p>
@@ -12143,7 +12143,7 @@
                 <a:ea typeface="Calibri" pitchFamily="34" charset="-122"/>
                 <a:cs typeface="Calibri" pitchFamily="34" charset="-120"/>
               </a:rPr>
-              <a:t>what the system does</a:t>
+              <a:t>deposit and refund rules</a:t>
             </a:r>
             <a:endParaRPr lang="en-US" sz="1200" dirty="0"/>
           </a:p>
@@ -12353,7 +12353,7 @@
                 <a:ea typeface="Calibri" pitchFamily="34" charset="-122"/>
                 <a:cs typeface="Calibri" pitchFamily="34" charset="-120"/>
               </a:rPr>
-              <a:t>analytics dashboards, demo support</a:t>
+              <a:t>analytics dashboards, live demo</a:t>
             </a:r>
             <a:endParaRPr lang="en-US" sz="1200" dirty="0"/>
           </a:p>
@@ -14164,7 +14164,7 @@
                 <a:ea typeface="Calibri" pitchFamily="34" charset="-122"/>
                 <a:cs typeface="Calibri" pitchFamily="34" charset="-120"/>
               </a:rPr>
-              <a:t>Then three short scenes: a waitlisted driver promoted to a real booking · a reliability score built from real history · a broken charger reported and resolved.</a:t>
+              <a:t>Then Abdel Aziz runs three short scenes: a waitlisted driver promoted to a real booking · a reliability score built from real history · a broken charger reported and resolved.</a:t>
             </a:r>
             <a:endParaRPr lang="en-US" sz="1300" dirty="0"/>
           </a:p>
@@ -17694,7 +17694,7 @@
                 <a:ea typeface="Calibri" pitchFamily="34" charset="-122"/>
                 <a:cs typeface="Calibri" pitchFamily="34" charset="-120"/>
               </a:rPr>
-              <a:t>Malik</a:t>
+              <a:t>Aya</a:t>
             </a:r>
             <a:endParaRPr lang="en-US" sz="1000" dirty="0"/>
           </a:p>

</xml_diff>